<commit_message>
Add Draw.io copy-code export and HGDY demo
</commit_message>
<xml_diff>
--- a/examples/academic-paper-demo/outputs/tech-route.pptx
+++ b/examples/academic-paper-demo/outputs/tech-route.pptx
@@ -94,17 +94,17 @@
         <p:spPr>
           <a:xfrm>
             <a:off x="2270155" y="330000"/>
-            <a:ext cx="7651689" cy="430000"/>
-          </a:xfrm>
-          <a:prstGeom prst="roundRect">
-            <a:avLst/>
-          </a:prstGeom>
-          <a:solidFill>
-            <a:srgbClr val="D8F0EA"/>
-          </a:solidFill>
-          <a:ln w="12700">
-            <a:solidFill>
-              <a:srgbClr val="7CB7C6"/>
+            <a:ext cx="7651689" cy="500000"/>
+          </a:xfrm>
+          <a:prstGeom prst="roundRect">
+            <a:avLst/>
+          </a:prstGeom>
+          <a:solidFill>
+            <a:srgbClr val="EFF6FF"/>
+          </a:solidFill>
+          <a:ln w="12700">
+            <a:solidFill>
+              <a:srgbClr val="E2E8F0"/>
             </a:solidFill>
           </a:ln>
         </p:spPr>
@@ -116,7 +116,7 @@
             <a:r>
               <a:rPr lang="zh-CN" sz="2100" b="1">
                 <a:solidFill>
-                  <a:srgbClr val="152E3A"/>
+                  <a:srgbClr val="0F172A"/>
                 </a:solidFill>
               </a:rPr>
               <a:t>多模态光伏缺陷检测方法技术路线图</a:t>
@@ -132,18 +132,18 @@
         </p:nvSpPr>
         <p:spPr>
           <a:xfrm>
-            <a:off x="2270155" y="775000"/>
-            <a:ext cx="7651689" cy="190000"/>
+            <a:off x="2270155" y="820000"/>
+            <a:ext cx="7651689" cy="210000"/>
           </a:xfrm>
           <a:prstGeom prst="rect">
             <a:avLst/>
           </a:prstGeom>
           <a:solidFill>
-            <a:srgbClr val="FFFFFF"/>
-          </a:solidFill>
-          <a:ln w="12700">
-            <a:solidFill>
-              <a:srgbClr val="FFFFFF"/>
+            <a:srgbClr val="F8FAFC"/>
+          </a:solidFill>
+          <a:ln w="12700">
+            <a:solidFill>
+              <a:srgbClr val="F8FAFC"/>
             </a:solidFill>
           </a:ln>
         </p:spPr>
@@ -155,21 +155,10 @@
             <a:r>
               <a:rPr lang="zh-CN" sz="850">
                 <a:solidFill>
-                  <a:srgbClr val="57717A"/>
-                </a:solidFill>
-              </a:rPr>
-              <a:t>中文论文方法框架示例：从图像证据到可</a:t>
-            </a:r>
-          </a:p>
-          <a:p>
-            <a:pPr algn="ctr"/>
-            <a:r>
-              <a:rPr lang="zh-CN" sz="850">
-                <a:solidFill>
-                  <a:srgbClr val="57717A"/>
-                </a:solidFill>
-              </a:rPr>
-              <a:t>验证检测结果</a:t>
+                  <a:srgbClr val="64748B"/>
+                </a:solidFill>
+              </a:rPr>
+              <a:t>中文论文方法框架示例：从图像证据到可验证检测结果</a:t>
             </a:r>
           </a:p>
         </p:txBody>
@@ -189,13 +178,12 @@
             <a:avLst/>
           </a:prstGeom>
           <a:solidFill>
-            <a:srgbClr val="D8F0EA"/>
-          </a:solidFill>
-          <a:ln w="12700">
-            <a:solidFill>
-              <a:srgbClr val="7CB7C6"/>
-            </a:solidFill>
-            <a:prstDash val="dash"/>
+            <a:srgbClr val="EFF6FF"/>
+          </a:solidFill>
+          <a:ln w="12700">
+            <a:solidFill>
+              <a:srgbClr val="E2E8F0"/>
+            </a:solidFill>
           </a:ln>
         </p:spPr>
         <p:txBody>
@@ -206,7 +194,7 @@
             <a:r>
               <a:rPr lang="zh-CN" sz="1000">
                 <a:solidFill>
-                  <a:srgbClr val="152E3A"/>
+                  <a:srgbClr val="0F172A"/>
                 </a:solidFill>
               </a:rPr>
               <a:t/>
@@ -229,11 +217,11 @@
             <a:avLst/>
           </a:prstGeom>
           <a:solidFill>
-            <a:srgbClr val="5AA6D6"/>
-          </a:solidFill>
-          <a:ln w="12700">
-            <a:solidFill>
-              <a:srgbClr val="5AA6D6"/>
+            <a:srgbClr val="2563EB"/>
+          </a:solidFill>
+          <a:ln w="12700">
+            <a:solidFill>
+              <a:srgbClr val="2563EB"/>
             </a:solidFill>
           </a:ln>
         </p:spPr>
@@ -268,13 +256,12 @@
             <a:avLst/>
           </a:prstGeom>
           <a:solidFill>
-            <a:srgbClr val="DDEBFB"/>
-          </a:solidFill>
-          <a:ln w="12700">
-            <a:solidFill>
-              <a:srgbClr val="7CB7C6"/>
-            </a:solidFill>
-            <a:prstDash val="dash"/>
+            <a:srgbClr val="F0FDF4"/>
+          </a:solidFill>
+          <a:ln w="12700">
+            <a:solidFill>
+              <a:srgbClr val="E2E8F0"/>
+            </a:solidFill>
           </a:ln>
         </p:spPr>
         <p:txBody>
@@ -285,7 +272,7 @@
             <a:r>
               <a:rPr lang="zh-CN" sz="1000">
                 <a:solidFill>
-                  <a:srgbClr val="152E3A"/>
+                  <a:srgbClr val="0F172A"/>
                 </a:solidFill>
               </a:rPr>
               <a:t/>
@@ -308,11 +295,11 @@
             <a:avLst/>
           </a:prstGeom>
           <a:solidFill>
-            <a:srgbClr val="5AA6D6"/>
-          </a:solidFill>
-          <a:ln w="12700">
-            <a:solidFill>
-              <a:srgbClr val="5AA6D6"/>
+            <a:srgbClr val="2563EB"/>
+          </a:solidFill>
+          <a:ln w="12700">
+            <a:solidFill>
+              <a:srgbClr val="2563EB"/>
             </a:solidFill>
           </a:ln>
         </p:spPr>
@@ -347,13 +334,12 @@
             <a:avLst/>
           </a:prstGeom>
           <a:solidFill>
-            <a:srgbClr val="EAF4D9"/>
-          </a:solidFill>
-          <a:ln w="12700">
-            <a:solidFill>
-              <a:srgbClr val="7CB7C6"/>
-            </a:solidFill>
-            <a:prstDash val="dash"/>
+            <a:srgbClr val="FEFCE8"/>
+          </a:solidFill>
+          <a:ln w="12700">
+            <a:solidFill>
+              <a:srgbClr val="E2E8F0"/>
+            </a:solidFill>
           </a:ln>
         </p:spPr>
         <p:txBody>
@@ -364,7 +350,7 @@
             <a:r>
               <a:rPr lang="zh-CN" sz="1000">
                 <a:solidFill>
-                  <a:srgbClr val="152E3A"/>
+                  <a:srgbClr val="0F172A"/>
                 </a:solidFill>
               </a:rPr>
               <a:t/>
@@ -387,11 +373,11 @@
             <a:avLst/>
           </a:prstGeom>
           <a:solidFill>
-            <a:srgbClr val="5AA6D6"/>
-          </a:solidFill>
-          <a:ln w="12700">
-            <a:solidFill>
-              <a:srgbClr val="5AA6D6"/>
+            <a:srgbClr val="2563EB"/>
+          </a:solidFill>
+          <a:ln w="12700">
+            <a:solidFill>
+              <a:srgbClr val="2563EB"/>
             </a:solidFill>
           </a:ln>
         </p:spPr>
@@ -426,13 +412,12 @@
             <a:avLst/>
           </a:prstGeom>
           <a:solidFill>
-            <a:srgbClr val="FFF0D4"/>
-          </a:solidFill>
-          <a:ln w="12700">
-            <a:solidFill>
-              <a:srgbClr val="7CB7C6"/>
-            </a:solidFill>
-            <a:prstDash val="dash"/>
+            <a:srgbClr val="FFF7ED"/>
+          </a:solidFill>
+          <a:ln w="12700">
+            <a:solidFill>
+              <a:srgbClr val="E2E8F0"/>
+            </a:solidFill>
           </a:ln>
         </p:spPr>
         <p:txBody>
@@ -443,7 +428,7 @@
             <a:r>
               <a:rPr lang="zh-CN" sz="1000">
                 <a:solidFill>
-                  <a:srgbClr val="152E3A"/>
+                  <a:srgbClr val="0F172A"/>
                 </a:solidFill>
               </a:rPr>
               <a:t/>
@@ -466,11 +451,11 @@
             <a:avLst/>
           </a:prstGeom>
           <a:solidFill>
-            <a:srgbClr val="5AA6D6"/>
-          </a:solidFill>
-          <a:ln w="12700">
-            <a:solidFill>
-              <a:srgbClr val="5AA6D6"/>
+            <a:srgbClr val="2563EB"/>
+          </a:solidFill>
+          <a:ln w="12700">
+            <a:solidFill>
+              <a:srgbClr val="2563EB"/>
             </a:solidFill>
           </a:ln>
         </p:spPr>
@@ -505,13 +490,12 @@
             <a:avLst/>
           </a:prstGeom>
           <a:solidFill>
-            <a:srgbClr val="F6E2E8"/>
-          </a:solidFill>
-          <a:ln w="12700">
-            <a:solidFill>
-              <a:srgbClr val="7CB7C6"/>
-            </a:solidFill>
-            <a:prstDash val="dash"/>
+            <a:srgbClr val="FDF2F8"/>
+          </a:solidFill>
+          <a:ln w="12700">
+            <a:solidFill>
+              <a:srgbClr val="E2E8F0"/>
+            </a:solidFill>
           </a:ln>
         </p:spPr>
         <p:txBody>
@@ -522,7 +506,7 @@
             <a:r>
               <a:rPr lang="zh-CN" sz="1000">
                 <a:solidFill>
-                  <a:srgbClr val="152E3A"/>
+                  <a:srgbClr val="0F172A"/>
                 </a:solidFill>
               </a:rPr>
               <a:t/>
@@ -545,11 +529,11 @@
             <a:avLst/>
           </a:prstGeom>
           <a:solidFill>
-            <a:srgbClr val="5AA6D6"/>
-          </a:solidFill>
-          <a:ln w="12700">
-            <a:solidFill>
-              <a:srgbClr val="5AA6D6"/>
+            <a:srgbClr val="2563EB"/>
+          </a:solidFill>
+          <a:ln w="12700">
+            <a:solidFill>
+              <a:srgbClr val="2563EB"/>
             </a:solidFill>
           </a:ln>
         </p:spPr>
@@ -577,15 +561,15 @@
         </p:nvCxnSpPr>
         <p:spPr>
           <a:xfrm>
-            <a:off x="5080689" y="1638361"/>
-            <a:ext cx="3052085" cy="1"/>
+            <a:off x="6606732" y="2081405"/>
+            <a:ext cx="1" cy="184601"/>
           </a:xfrm>
           <a:prstGeom prst="line">
             <a:avLst/>
           </a:prstGeom>
           <a:ln w="19050">
             <a:solidFill>
-              <a:srgbClr val="2F7CA6"/>
+              <a:srgbClr val="64748B"/>
             </a:solidFill>
             <a:headEnd type="triangle"/>
           </a:ln>
@@ -598,16 +582,16 @@
           <p:nvPr/>
         </p:nvCxnSpPr>
         <p:spPr>
-          <a:xfrm flipH="1">
-            <a:off x="4572008" y="1638361"/>
-            <a:ext cx="3560766" cy="1021464"/>
+          <a:xfrm>
+            <a:off x="6606732" y="3102869"/>
+            <a:ext cx="1" cy="184601"/>
           </a:xfrm>
           <a:prstGeom prst="line">
             <a:avLst/>
           </a:prstGeom>
           <a:ln w="19050">
             <a:solidFill>
-              <a:srgbClr val="2F7CA6"/>
+              <a:srgbClr val="64748B"/>
             </a:solidFill>
             <a:headEnd type="triangle"/>
           </a:ln>
@@ -621,15 +605,15 @@
         </p:nvCxnSpPr>
         <p:spPr>
           <a:xfrm>
-            <a:off x="4572008" y="2659825"/>
-            <a:ext cx="2034723" cy="1"/>
+            <a:off x="6606732" y="4124333"/>
+            <a:ext cx="1" cy="184601"/>
           </a:xfrm>
           <a:prstGeom prst="line">
             <a:avLst/>
           </a:prstGeom>
           <a:ln w="19050">
             <a:solidFill>
-              <a:srgbClr val="2F7CA6"/>
+              <a:srgbClr val="64748B"/>
             </a:solidFill>
             <a:headEnd type="triangle"/>
           </a:ln>
@@ -643,221 +627,23 @@
         </p:nvCxnSpPr>
         <p:spPr>
           <a:xfrm>
-            <a:off x="6606732" y="2659825"/>
-            <a:ext cx="2034723" cy="1"/>
+            <a:off x="6606732" y="5145798"/>
+            <a:ext cx="1" cy="184601"/>
           </a:xfrm>
           <a:prstGeom prst="line">
             <a:avLst/>
           </a:prstGeom>
           <a:ln w="19050">
             <a:solidFill>
-              <a:srgbClr val="2F7CA6"/>
+              <a:srgbClr val="64748B"/>
             </a:solidFill>
             <a:headEnd type="triangle"/>
           </a:ln>
         </p:spPr>
       </p:cxnSp>
-      <p:cxnSp>
-        <p:nvCxnSpPr>
-          <p:cNvPr id="18" name="Connector 18"/>
-          <p:cNvCxnSpPr/>
-          <p:nvPr/>
-        </p:nvCxnSpPr>
-        <p:spPr>
-          <a:xfrm flipH="1">
-            <a:off x="4572008" y="2659825"/>
-            <a:ext cx="4069447" cy="1021464"/>
-          </a:xfrm>
-          <a:prstGeom prst="line">
-            <a:avLst/>
-          </a:prstGeom>
-          <a:ln w="19050">
-            <a:solidFill>
-              <a:srgbClr val="2F7CA6"/>
-            </a:solidFill>
-            <a:headEnd type="triangle"/>
-          </a:ln>
-        </p:spPr>
-      </p:cxnSp>
-      <p:cxnSp>
-        <p:nvCxnSpPr>
-          <p:cNvPr id="19" name="Connector 19"/>
-          <p:cNvCxnSpPr/>
-          <p:nvPr/>
-        </p:nvCxnSpPr>
-        <p:spPr>
-          <a:xfrm>
-            <a:off x="4572008" y="3681289"/>
-            <a:ext cx="2034723" cy="1"/>
-          </a:xfrm>
-          <a:prstGeom prst="line">
-            <a:avLst/>
-          </a:prstGeom>
-          <a:ln w="19050">
-            <a:solidFill>
-              <a:srgbClr val="2F7CA6"/>
-            </a:solidFill>
-            <a:headEnd type="triangle"/>
-          </a:ln>
-        </p:spPr>
-      </p:cxnSp>
-      <p:cxnSp>
-        <p:nvCxnSpPr>
-          <p:cNvPr id="20" name="Connector 20"/>
-          <p:cNvCxnSpPr/>
-          <p:nvPr/>
-        </p:nvCxnSpPr>
-        <p:spPr>
-          <a:xfrm>
-            <a:off x="6606732" y="3681289"/>
-            <a:ext cx="2034723" cy="1"/>
-          </a:xfrm>
-          <a:prstGeom prst="line">
-            <a:avLst/>
-          </a:prstGeom>
-          <a:ln w="19050">
-            <a:solidFill>
-              <a:srgbClr val="2F7CA6"/>
-            </a:solidFill>
-            <a:headEnd type="triangle"/>
-          </a:ln>
-        </p:spPr>
-      </p:cxnSp>
-      <p:cxnSp>
-        <p:nvCxnSpPr>
-          <p:cNvPr id="21" name="Connector 21"/>
-          <p:cNvCxnSpPr/>
-          <p:nvPr/>
-        </p:nvCxnSpPr>
-        <p:spPr>
-          <a:xfrm flipH="1">
-            <a:off x="4572008" y="3681289"/>
-            <a:ext cx="4069447" cy="1021464"/>
-          </a:xfrm>
-          <a:prstGeom prst="line">
-            <a:avLst/>
-          </a:prstGeom>
-          <a:ln w="19050">
-            <a:solidFill>
-              <a:srgbClr val="2F7CA6"/>
-            </a:solidFill>
-            <a:headEnd type="triangle"/>
-          </a:ln>
-        </p:spPr>
-      </p:cxnSp>
-      <p:cxnSp>
-        <p:nvCxnSpPr>
-          <p:cNvPr id="22" name="Connector 22"/>
-          <p:cNvCxnSpPr/>
-          <p:nvPr/>
-        </p:nvCxnSpPr>
-        <p:spPr>
-          <a:xfrm>
-            <a:off x="4572008" y="4702753"/>
-            <a:ext cx="2034723" cy="1"/>
-          </a:xfrm>
-          <a:prstGeom prst="line">
-            <a:avLst/>
-          </a:prstGeom>
-          <a:ln w="19050">
-            <a:solidFill>
-              <a:srgbClr val="2F7CA6"/>
-            </a:solidFill>
-            <a:headEnd type="triangle"/>
-          </a:ln>
-        </p:spPr>
-      </p:cxnSp>
-      <p:cxnSp>
-        <p:nvCxnSpPr>
-          <p:cNvPr id="23" name="Connector 23"/>
-          <p:cNvCxnSpPr/>
-          <p:nvPr/>
-        </p:nvCxnSpPr>
-        <p:spPr>
-          <a:xfrm>
-            <a:off x="6606732" y="4702753"/>
-            <a:ext cx="2034723" cy="1"/>
-          </a:xfrm>
-          <a:prstGeom prst="line">
-            <a:avLst/>
-          </a:prstGeom>
-          <a:ln w="19050">
-            <a:solidFill>
-              <a:srgbClr val="2F7CA6"/>
-            </a:solidFill>
-            <a:headEnd type="triangle"/>
-          </a:ln>
-        </p:spPr>
-      </p:cxnSp>
-      <p:cxnSp>
-        <p:nvCxnSpPr>
-          <p:cNvPr id="24" name="Connector 24"/>
-          <p:cNvCxnSpPr/>
-          <p:nvPr/>
-        </p:nvCxnSpPr>
-        <p:spPr>
-          <a:xfrm flipH="1">
-            <a:off x="4572008" y="4702753"/>
-            <a:ext cx="4069447" cy="1021464"/>
-          </a:xfrm>
-          <a:prstGeom prst="line">
-            <a:avLst/>
-          </a:prstGeom>
-          <a:ln w="19050">
-            <a:solidFill>
-              <a:srgbClr val="2F7CA6"/>
-            </a:solidFill>
-            <a:headEnd type="triangle"/>
-          </a:ln>
-        </p:spPr>
-      </p:cxnSp>
-      <p:cxnSp>
-        <p:nvCxnSpPr>
-          <p:cNvPr id="25" name="Connector 25"/>
-          <p:cNvCxnSpPr/>
-          <p:nvPr/>
-        </p:nvCxnSpPr>
-        <p:spPr>
-          <a:xfrm>
-            <a:off x="4572008" y="5724217"/>
-            <a:ext cx="2034723" cy="1"/>
-          </a:xfrm>
-          <a:prstGeom prst="line">
-            <a:avLst/>
-          </a:prstGeom>
-          <a:ln w="19050">
-            <a:solidFill>
-              <a:srgbClr val="2F7CA6"/>
-            </a:solidFill>
-            <a:headEnd type="triangle"/>
-          </a:ln>
-        </p:spPr>
-      </p:cxnSp>
-      <p:cxnSp>
-        <p:nvCxnSpPr>
-          <p:cNvPr id="26" name="Connector 26"/>
-          <p:cNvCxnSpPr/>
-          <p:nvPr/>
-        </p:nvCxnSpPr>
-        <p:spPr>
-          <a:xfrm>
-            <a:off x="6606732" y="5724217"/>
-            <a:ext cx="2034723" cy="1"/>
-          </a:xfrm>
-          <a:prstGeom prst="line">
-            <a:avLst/>
-          </a:prstGeom>
-          <a:ln w="19050">
-            <a:solidFill>
-              <a:srgbClr val="2F7CA6"/>
-            </a:solidFill>
-            <a:headEnd type="triangle"/>
-          </a:ln>
-        </p:spPr>
-      </p:cxnSp>
-      <p:sp>
-        <p:nvSpPr>
-          <p:cNvPr id="27" name="Node goal_task"/>
+      <p:sp>
+        <p:nvSpPr>
+          <p:cNvPr id="18" name="Node goal_task"/>
           <p:cNvSpPr/>
           <p:nvPr/>
         </p:nvSpPr>
@@ -874,19 +660,19 @@
           </a:solidFill>
           <a:ln w="12700">
             <a:solidFill>
-              <a:srgbClr val="9EB7C8"/>
-            </a:solidFill>
-          </a:ln>
-        </p:spPr>
-        <p:txBody>
-          <a:bodyPr wrap="square" anchor="ctr"/>
-          <a:lstStyle/>
-          <a:p>
-            <a:pPr algn="ctr"/>
-            <a:r>
-              <a:rPr lang="zh-CN" sz="980">
-                <a:solidFill>
-                  <a:srgbClr val="152E3A"/>
+              <a:srgbClr val="CBD5E1"/>
+            </a:solidFill>
+          </a:ln>
+        </p:spPr>
+        <p:txBody>
+          <a:bodyPr wrap="square" anchor="ctr"/>
+          <a:lstStyle/>
+          <a:p>
+            <a:pPr algn="ctr"/>
+            <a:r>
+              <a:rPr lang="zh-CN" sz="930">
+                <a:solidFill>
+                  <a:srgbClr val="0F172A"/>
                 </a:solidFill>
               </a:rPr>
               <a:t>明确缺陷检测任务</a:t>
@@ -896,7 +682,7 @@
       </p:sp>
       <p:sp>
         <p:nvSpPr>
-          <p:cNvPr id="28" name="Node goal_metric"/>
+          <p:cNvPr id="19" name="Node goal_metric"/>
           <p:cNvSpPr/>
           <p:nvPr/>
         </p:nvSpPr>
@@ -913,19 +699,19 @@
           </a:solidFill>
           <a:ln w="12700">
             <a:solidFill>
-              <a:srgbClr val="9EB7C8"/>
-            </a:solidFill>
-          </a:ln>
-        </p:spPr>
-        <p:txBody>
-          <a:bodyPr wrap="square" anchor="ctr"/>
-          <a:lstStyle/>
-          <a:p>
-            <a:pPr algn="ctr"/>
-            <a:r>
-              <a:rPr lang="zh-CN" sz="980">
-                <a:solidFill>
-                  <a:srgbClr val="152E3A"/>
+              <a:srgbClr val="CBD5E1"/>
+            </a:solidFill>
+          </a:ln>
+        </p:spPr>
+        <p:txBody>
+          <a:bodyPr wrap="square" anchor="ctr"/>
+          <a:lstStyle/>
+          <a:p>
+            <a:pPr algn="ctr"/>
+            <a:r>
+              <a:rPr lang="zh-CN" sz="930">
+                <a:solidFill>
+                  <a:srgbClr val="0F172A"/>
                 </a:solidFill>
               </a:rPr>
               <a:t>设定评价指标</a:t>
@@ -935,7 +721,7 @@
       </p:sp>
       <p:sp>
         <p:nvSpPr>
-          <p:cNvPr id="29" name="Node data_collect"/>
+          <p:cNvPr id="20" name="Node data_collect"/>
           <p:cNvSpPr/>
           <p:nvPr/>
         </p:nvSpPr>
@@ -952,19 +738,19 @@
           </a:solidFill>
           <a:ln w="12700">
             <a:solidFill>
-              <a:srgbClr val="9EB7C8"/>
-            </a:solidFill>
-          </a:ln>
-        </p:spPr>
-        <p:txBody>
-          <a:bodyPr wrap="square" anchor="ctr"/>
-          <a:lstStyle/>
-          <a:p>
-            <a:pPr algn="ctr"/>
-            <a:r>
-              <a:rPr lang="zh-CN" sz="980">
-                <a:solidFill>
-                  <a:srgbClr val="152E3A"/>
+              <a:srgbClr val="CBD5E1"/>
+            </a:solidFill>
+          </a:ln>
+        </p:spPr>
+        <p:txBody>
+          <a:bodyPr wrap="square" anchor="ctr"/>
+          <a:lstStyle/>
+          <a:p>
+            <a:pPr algn="ctr"/>
+            <a:r>
+              <a:rPr lang="zh-CN" sz="930">
+                <a:solidFill>
+                  <a:srgbClr val="0F172A"/>
                 </a:solidFill>
               </a:rPr>
               <a:t>采集多模态图像</a:t>
@@ -974,7 +760,7 @@
       </p:sp>
       <p:sp>
         <p:nvSpPr>
-          <p:cNvPr id="30" name="Node data_align"/>
+          <p:cNvPr id="21" name="Node data_align"/>
           <p:cNvSpPr/>
           <p:nvPr/>
         </p:nvSpPr>
@@ -991,19 +777,19 @@
           </a:solidFill>
           <a:ln w="12700">
             <a:solidFill>
-              <a:srgbClr val="9EB7C8"/>
-            </a:solidFill>
-          </a:ln>
-        </p:spPr>
-        <p:txBody>
-          <a:bodyPr wrap="square" anchor="ctr"/>
-          <a:lstStyle/>
-          <a:p>
-            <a:pPr algn="ctr"/>
-            <a:r>
-              <a:rPr lang="zh-CN" sz="980">
-                <a:solidFill>
-                  <a:srgbClr val="152E3A"/>
+              <a:srgbClr val="CBD5E1"/>
+            </a:solidFill>
+          </a:ln>
+        </p:spPr>
+        <p:txBody>
+          <a:bodyPr wrap="square" anchor="ctr"/>
+          <a:lstStyle/>
+          <a:p>
+            <a:pPr algn="ctr"/>
+            <a:r>
+              <a:rPr lang="zh-CN" sz="930">
+                <a:solidFill>
+                  <a:srgbClr val="0F172A"/>
                 </a:solidFill>
               </a:rPr>
               <a:t>配准并标注缺陷</a:t>
@@ -1013,7 +799,7 @@
       </p:sp>
       <p:sp>
         <p:nvSpPr>
-          <p:cNvPr id="31" name="Node data_split"/>
+          <p:cNvPr id="22" name="Node data_split"/>
           <p:cNvSpPr/>
           <p:nvPr/>
         </p:nvSpPr>
@@ -1030,19 +816,19 @@
           </a:solidFill>
           <a:ln w="12700">
             <a:solidFill>
-              <a:srgbClr val="9EB7C8"/>
-            </a:solidFill>
-          </a:ln>
-        </p:spPr>
-        <p:txBody>
-          <a:bodyPr wrap="square" anchor="ctr"/>
-          <a:lstStyle/>
-          <a:p>
-            <a:pPr algn="ctr"/>
-            <a:r>
-              <a:rPr lang="zh-CN" sz="980">
-                <a:solidFill>
-                  <a:srgbClr val="152E3A"/>
+              <a:srgbClr val="CBD5E1"/>
+            </a:solidFill>
+          </a:ln>
+        </p:spPr>
+        <p:txBody>
+          <a:bodyPr wrap="square" anchor="ctr"/>
+          <a:lstStyle/>
+          <a:p>
+            <a:pPr algn="ctr"/>
+            <a:r>
+              <a:rPr lang="zh-CN" sz="930">
+                <a:solidFill>
+                  <a:srgbClr val="0F172A"/>
                 </a:solidFill>
               </a:rPr>
               <a:t>划分训练样本</a:t>
@@ -1052,7 +838,7 @@
       </p:sp>
       <p:sp>
         <p:nvSpPr>
-          <p:cNvPr id="32" name="Node method_baseline"/>
+          <p:cNvPr id="23" name="Node method_baseline"/>
           <p:cNvSpPr/>
           <p:nvPr/>
         </p:nvSpPr>
@@ -1069,19 +855,19 @@
           </a:solidFill>
           <a:ln w="12700">
             <a:solidFill>
-              <a:srgbClr val="9EB7C8"/>
-            </a:solidFill>
-          </a:ln>
-        </p:spPr>
-        <p:txBody>
-          <a:bodyPr wrap="square" anchor="ctr"/>
-          <a:lstStyle/>
-          <a:p>
-            <a:pPr algn="ctr"/>
-            <a:r>
-              <a:rPr lang="zh-CN" sz="980">
-                <a:solidFill>
-                  <a:srgbClr val="152E3A"/>
+              <a:srgbClr val="CBD5E1"/>
+            </a:solidFill>
+          </a:ln>
+        </p:spPr>
+        <p:txBody>
+          <a:bodyPr wrap="square" anchor="ctr"/>
+          <a:lstStyle/>
+          <a:p>
+            <a:pPr algn="ctr"/>
+            <a:r>
+              <a:rPr lang="zh-CN" sz="930">
+                <a:solidFill>
+                  <a:srgbClr val="0F172A"/>
                 </a:solidFill>
               </a:rPr>
               <a:t>建立基线检测器</a:t>
@@ -1091,7 +877,7 @@
       </p:sp>
       <p:sp>
         <p:nvSpPr>
-          <p:cNvPr id="33" name="Node method_fusion"/>
+          <p:cNvPr id="24" name="Node method_fusion"/>
           <p:cNvSpPr/>
           <p:nvPr/>
         </p:nvSpPr>
@@ -1108,19 +894,19 @@
           </a:solidFill>
           <a:ln w="12700">
             <a:solidFill>
-              <a:srgbClr val="9EB7C8"/>
-            </a:solidFill>
-          </a:ln>
-        </p:spPr>
-        <p:txBody>
-          <a:bodyPr wrap="square" anchor="ctr"/>
-          <a:lstStyle/>
-          <a:p>
-            <a:pPr algn="ctr"/>
-            <a:r>
-              <a:rPr lang="zh-CN" sz="980">
-                <a:solidFill>
-                  <a:srgbClr val="152E3A"/>
+              <a:srgbClr val="CBD5E1"/>
+            </a:solidFill>
+          </a:ln>
+        </p:spPr>
+        <p:txBody>
+          <a:bodyPr wrap="square" anchor="ctr"/>
+          <a:lstStyle/>
+          <a:p>
+            <a:pPr algn="ctr"/>
+            <a:r>
+              <a:rPr lang="zh-CN" sz="930">
+                <a:solidFill>
+                  <a:srgbClr val="0F172A"/>
                 </a:solidFill>
               </a:rPr>
               <a:t>构建跨模态融合</a:t>
@@ -1130,7 +916,7 @@
       </p:sp>
       <p:sp>
         <p:nvSpPr>
-          <p:cNvPr id="34" name="Node method_attention"/>
+          <p:cNvPr id="25" name="Node method_attention"/>
           <p:cNvSpPr/>
           <p:nvPr/>
         </p:nvSpPr>
@@ -1147,19 +933,19 @@
           </a:solidFill>
           <a:ln w="12700">
             <a:solidFill>
-              <a:srgbClr val="9EB7C8"/>
-            </a:solidFill>
-          </a:ln>
-        </p:spPr>
-        <p:txBody>
-          <a:bodyPr wrap="square" anchor="ctr"/>
-          <a:lstStyle/>
-          <a:p>
-            <a:pPr algn="ctr"/>
-            <a:r>
-              <a:rPr lang="zh-CN" sz="980">
-                <a:solidFill>
-                  <a:srgbClr val="152E3A"/>
+              <a:srgbClr val="CBD5E1"/>
+            </a:solidFill>
+          </a:ln>
+        </p:spPr>
+        <p:txBody>
+          <a:bodyPr wrap="square" anchor="ctr"/>
+          <a:lstStyle/>
+          <a:p>
+            <a:pPr algn="ctr"/>
+            <a:r>
+              <a:rPr lang="zh-CN" sz="930">
+                <a:solidFill>
+                  <a:srgbClr val="0F172A"/>
                 </a:solidFill>
               </a:rPr>
               <a:t>增强关键区域感知</a:t>
@@ -1169,7 +955,7 @@
       </p:sp>
       <p:sp>
         <p:nvSpPr>
-          <p:cNvPr id="35" name="Node training_loss"/>
+          <p:cNvPr id="26" name="Node training_loss"/>
           <p:cNvSpPr/>
           <p:nvPr/>
         </p:nvSpPr>
@@ -1186,19 +972,19 @@
           </a:solidFill>
           <a:ln w="12700">
             <a:solidFill>
-              <a:srgbClr val="9EB7C8"/>
-            </a:solidFill>
-          </a:ln>
-        </p:spPr>
-        <p:txBody>
-          <a:bodyPr wrap="square" anchor="ctr"/>
-          <a:lstStyle/>
-          <a:p>
-            <a:pPr algn="ctr"/>
-            <a:r>
-              <a:rPr lang="zh-CN" sz="980">
-                <a:solidFill>
-                  <a:srgbClr val="152E3A"/>
+              <a:srgbClr val="CBD5E1"/>
+            </a:solidFill>
+          </a:ln>
+        </p:spPr>
+        <p:txBody>
+          <a:bodyPr wrap="square" anchor="ctr"/>
+          <a:lstStyle/>
+          <a:p>
+            <a:pPr algn="ctr"/>
+            <a:r>
+              <a:rPr lang="zh-CN" sz="930">
+                <a:solidFill>
+                  <a:srgbClr val="0F172A"/>
                 </a:solidFill>
               </a:rPr>
               <a:t>优化检测损失</a:t>
@@ -1208,7 +994,7 @@
       </p:sp>
       <p:sp>
         <p:nvSpPr>
-          <p:cNvPr id="36" name="Node training_ablation"/>
+          <p:cNvPr id="27" name="Node training_ablation"/>
           <p:cNvSpPr/>
           <p:nvPr/>
         </p:nvSpPr>
@@ -1225,19 +1011,19 @@
           </a:solidFill>
           <a:ln w="12700">
             <a:solidFill>
-              <a:srgbClr val="9EB7C8"/>
-            </a:solidFill>
-          </a:ln>
-        </p:spPr>
-        <p:txBody>
-          <a:bodyPr wrap="square" anchor="ctr"/>
-          <a:lstStyle/>
-          <a:p>
-            <a:pPr algn="ctr"/>
-            <a:r>
-              <a:rPr lang="zh-CN" sz="980">
-                <a:solidFill>
-                  <a:srgbClr val="152E3A"/>
+              <a:srgbClr val="CBD5E1"/>
+            </a:solidFill>
+          </a:ln>
+        </p:spPr>
+        <p:txBody>
+          <a:bodyPr wrap="square" anchor="ctr"/>
+          <a:lstStyle/>
+          <a:p>
+            <a:pPr algn="ctr"/>
+            <a:r>
+              <a:rPr lang="zh-CN" sz="930">
+                <a:solidFill>
+                  <a:srgbClr val="0F172A"/>
                 </a:solidFill>
               </a:rPr>
               <a:t>开展消融实验</a:t>
@@ -1247,7 +1033,7 @@
       </p:sp>
       <p:sp>
         <p:nvSpPr>
-          <p:cNvPr id="37" name="Node training_infer"/>
+          <p:cNvPr id="28" name="Node training_infer"/>
           <p:cNvSpPr/>
           <p:nvPr/>
         </p:nvSpPr>
@@ -1264,19 +1050,19 @@
           </a:solidFill>
           <a:ln w="12700">
             <a:solidFill>
-              <a:srgbClr val="9EB7C8"/>
-            </a:solidFill>
-          </a:ln>
-        </p:spPr>
-        <p:txBody>
-          <a:bodyPr wrap="square" anchor="ctr"/>
-          <a:lstStyle/>
-          <a:p>
-            <a:pPr algn="ctr"/>
-            <a:r>
-              <a:rPr lang="zh-CN" sz="980">
-                <a:solidFill>
-                  <a:srgbClr val="152E3A"/>
+              <a:srgbClr val="CBD5E1"/>
+            </a:solidFill>
+          </a:ln>
+        </p:spPr>
+        <p:txBody>
+          <a:bodyPr wrap="square" anchor="ctr"/>
+          <a:lstStyle/>
+          <a:p>
+            <a:pPr algn="ctr"/>
+            <a:r>
+              <a:rPr lang="zh-CN" sz="930">
+                <a:solidFill>
+                  <a:srgbClr val="0F172A"/>
                 </a:solidFill>
               </a:rPr>
               <a:t>推理并筛选结果</a:t>
@@ -1286,7 +1072,7 @@
       </p:sp>
       <p:sp>
         <p:nvSpPr>
-          <p:cNvPr id="38" name="Node output_metrics"/>
+          <p:cNvPr id="29" name="Node output_metrics"/>
           <p:cNvSpPr/>
           <p:nvPr/>
         </p:nvSpPr>
@@ -1303,19 +1089,19 @@
           </a:solidFill>
           <a:ln w="12700">
             <a:solidFill>
-              <a:srgbClr val="9EB7C8"/>
-            </a:solidFill>
-          </a:ln>
-        </p:spPr>
-        <p:txBody>
-          <a:bodyPr wrap="square" anchor="ctr"/>
-          <a:lstStyle/>
-          <a:p>
-            <a:pPr algn="ctr"/>
-            <a:r>
-              <a:rPr lang="zh-CN" sz="980">
-                <a:solidFill>
-                  <a:srgbClr val="152E3A"/>
+              <a:srgbClr val="CBD5E1"/>
+            </a:solidFill>
+          </a:ln>
+        </p:spPr>
+        <p:txBody>
+          <a:bodyPr wrap="square" anchor="ctr"/>
+          <a:lstStyle/>
+          <a:p>
+            <a:pPr algn="ctr"/>
+            <a:r>
+              <a:rPr lang="zh-CN" sz="930">
+                <a:solidFill>
+                  <a:srgbClr val="0F172A"/>
                 </a:solidFill>
               </a:rPr>
               <a:t>完成指标评估</a:t>
@@ -1325,7 +1111,7 @@
       </p:sp>
       <p:sp>
         <p:nvSpPr>
-          <p:cNvPr id="39" name="Node output_visual"/>
+          <p:cNvPr id="30" name="Node output_visual"/>
           <p:cNvSpPr/>
           <p:nvPr/>
         </p:nvSpPr>
@@ -1342,19 +1128,19 @@
           </a:solidFill>
           <a:ln w="12700">
             <a:solidFill>
-              <a:srgbClr val="9EB7C8"/>
-            </a:solidFill>
-          </a:ln>
-        </p:spPr>
-        <p:txBody>
-          <a:bodyPr wrap="square" anchor="ctr"/>
-          <a:lstStyle/>
-          <a:p>
-            <a:pPr algn="ctr"/>
-            <a:r>
-              <a:rPr lang="zh-CN" sz="980">
-                <a:solidFill>
-                  <a:srgbClr val="152E3A"/>
+              <a:srgbClr val="CBD5E1"/>
+            </a:solidFill>
+          </a:ln>
+        </p:spPr>
+        <p:txBody>
+          <a:bodyPr wrap="square" anchor="ctr"/>
+          <a:lstStyle/>
+          <a:p>
+            <a:pPr algn="ctr"/>
+            <a:r>
+              <a:rPr lang="zh-CN" sz="930">
+                <a:solidFill>
+                  <a:srgbClr val="0F172A"/>
                 </a:solidFill>
               </a:rPr>
               <a:t>生成可视化解释</a:t>
@@ -1364,7 +1150,7 @@
       </p:sp>
       <p:sp>
         <p:nvSpPr>
-          <p:cNvPr id="40" name="Node output_report"/>
+          <p:cNvPr id="31" name="Node output_report"/>
           <p:cNvSpPr/>
           <p:nvPr/>
         </p:nvSpPr>
@@ -1381,19 +1167,19 @@
           </a:solidFill>
           <a:ln w="12700">
             <a:solidFill>
-              <a:srgbClr val="9EB7C8"/>
-            </a:solidFill>
-          </a:ln>
-        </p:spPr>
-        <p:txBody>
-          <a:bodyPr wrap="square" anchor="ctr"/>
-          <a:lstStyle/>
-          <a:p>
-            <a:pPr algn="ctr"/>
-            <a:r>
-              <a:rPr lang="zh-CN" sz="980">
-                <a:solidFill>
-                  <a:srgbClr val="152E3A"/>
+              <a:srgbClr val="CBD5E1"/>
+            </a:solidFill>
+          </a:ln>
+        </p:spPr>
+        <p:txBody>
+          <a:bodyPr wrap="square" anchor="ctr"/>
+          <a:lstStyle/>
+          <a:p>
+            <a:pPr algn="ctr"/>
+            <a:r>
+              <a:rPr lang="zh-CN" sz="930">
+                <a:solidFill>
+                  <a:srgbClr val="0F172A"/>
                 </a:solidFill>
               </a:rPr>
               <a:t>输出缺陷报告</a:t>

</xml_diff>